<commit_message>
All figures: grayscale/B&W print compatibility
- Fig 1,3 (bar charts): hatching patterns + gray shades per region
- Fig 2,4 (scatter plots): distinct marker shapes + gray shades per region
- Updated captions: remove 'coloured' references, describe marker/hatch distinction
- EN + JA versions updated consistently

Co-Authored-By: Tatsuki Onishi <bougtoir@gmail.com>
</commit_message>
<xml_diff>
--- a/ndb-pain-regional-variation-japan/output/je/JE_figures_EN.pptx
+++ b/ndb-pain-regional-variation-japan/output/je/JE_figures_EN.pptx
@@ -3141,7 +3141,7 @@
         <p:spPr>
           <a:xfrm>
             <a:off x="1066647" y="731520"/>
-            <a:ext cx="10058400" cy="4360748"/>
+            <a:ext cx="10058400" cy="4355792"/>
           </a:xfrm>
           <a:prstGeom prst="rect">
             <a:avLst/>
@@ -3156,7 +3156,7 @@
         </p:nvSpPr>
         <p:spPr>
           <a:xfrm>
-            <a:off x="457200" y="5183708"/>
+            <a:off x="457200" y="5178752"/>
             <a:ext cx="10972800" cy="914400"/>
           </a:xfrm>
           <a:prstGeom prst="rect">
@@ -3176,7 +3176,7 @@
               </a:defRPr>
             </a:pPr>
             <a:r>
-              <a:t>Figure 1. Outpatient neuropathic pain drug prescribing per surgery by prefecture. Bars represent individual prefectures ordered by prescribing index. Bars are coloured by regional block. Dashed line indicates the national mean.</a:t>
+              <a:t>Figure 1. Outpatient neuropathic pain drug prescribing per surgery by prefecture. Bars represent individual prefectures ordered by prescribing index. Bars indicate regional blocks (distinguished by shading and hatch pattern). Dashed line indicates the national mean.</a:t>
             </a:r>
           </a:p>
         </p:txBody>
@@ -3248,8 +3248,8 @@
         </p:blipFill>
         <p:spPr>
           <a:xfrm>
-            <a:off x="3300358" y="731520"/>
-            <a:ext cx="5590979" cy="5029200"/>
+            <a:off x="3240714" y="731520"/>
+            <a:ext cx="5710266" cy="5029200"/>
           </a:xfrm>
           <a:prstGeom prst="rect">
             <a:avLst/>
@@ -3284,7 +3284,7 @@
               </a:defRPr>
             </a:pPr>
             <a:r>
-              <a:t>Figure 2. Correlation between neuropathic pain prescribing and confounder disease proxies across 47 prefectures. Each dot represents one prefecture. Diabetes drugs show the strongest correlation (r=0.87).</a:t>
+              <a:t>Figure 2. Correlation between neuropathic pain prescribing and confounder disease proxies across 47 prefectures. Each marker shape represents a regional block. Diabetes drugs show the strongest correlation (r=0.87).</a:t>
             </a:r>
           </a:p>
         </p:txBody>
@@ -3357,7 +3357,7 @@
         <p:spPr>
           <a:xfrm>
             <a:off x="1066647" y="731520"/>
-            <a:ext cx="10058400" cy="4364966"/>
+            <a:ext cx="10058400" cy="4328677"/>
           </a:xfrm>
           <a:prstGeom prst="rect">
             <a:avLst/>
@@ -3372,7 +3372,7 @@
         </p:nvSpPr>
         <p:spPr>
           <a:xfrm>
-            <a:off x="457200" y="5187926"/>
+            <a:off x="457200" y="5151637"/>
             <a:ext cx="10972800" cy="914400"/>
           </a:xfrm>
           <a:prstGeom prst="rect">
@@ -3500,7 +3500,7 @@
               </a:defRPr>
             </a:pPr>
             <a:r>
-              <a:t>Figure 4. Demand–supply dissociation: CSLC symptom prevalence rate (per 1,000 population) vs acute analgesic prescribing per surgery across 47 prefectures. Each dot represents one prefecture, coloured by regional block. The near-zero correlation (r=0.03, P=0.85) indicates that prescribing variation is dissociated from symptom burden.</a:t>
+              <a:t>Figure 4. Demand–supply dissociation: CSLC symptom prevalence rate (per 1,000 population) vs acute analgesic prescribing per surgery across 47 prefectures. Each marker shape represents a regional block. The near-zero correlation (r=0.03, P=0.85) indicates that prescribing variation is dissociated from symptom burden.</a:t>
             </a:r>
           </a:p>
         </p:txBody>

</xml_diff>

<commit_message>
Restore colours: colour + hatch/marker for dual print compatibility
Bars: original colours preserved, hatching overlay added for B&W
Scatter: original colours preserved, distinct marker shapes added for B&W
Captions updated to describe 'colour and hatch/shape' distinction

Co-Authored-By: Tatsuki Onishi <bougtoir@gmail.com>
</commit_message>
<xml_diff>
--- a/ndb-pain-regional-variation-japan/output/je/JE_figures_EN.pptx
+++ b/ndb-pain-regional-variation-japan/output/je/JE_figures_EN.pptx
@@ -3176,7 +3176,7 @@
               </a:defRPr>
             </a:pPr>
             <a:r>
-              <a:t>Figure 1. Outpatient neuropathic pain drug prescribing per surgery by prefecture. Bars represent individual prefectures ordered by prescribing index. Bars indicate regional blocks (distinguished by shading and hatch pattern). Dashed line indicates the national mean.</a:t>
+              <a:t>Figure 1. Outpatient neuropathic pain drug prescribing per surgery by prefecture. Bars represent individual prefectures ordered by prescribing index. Bars indicate regional blocks (distinguished by colour and hatch pattern). Dashed line indicates the national mean.</a:t>
             </a:r>
           </a:p>
         </p:txBody>
@@ -3284,7 +3284,7 @@
               </a:defRPr>
             </a:pPr>
             <a:r>
-              <a:t>Figure 2. Correlation between neuropathic pain prescribing and confounder disease proxies across 47 prefectures. Each marker shape represents a regional block. Diabetes drugs show the strongest correlation (r=0.87).</a:t>
+              <a:t>Figure 2. Correlation between neuropathic pain prescribing and confounder disease proxies across 47 prefectures. Each marker represents a regional block (distinguished by colour and shape). Diabetes drugs show the strongest correlation (r=0.87).</a:t>
             </a:r>
           </a:p>
         </p:txBody>
@@ -3500,7 +3500,7 @@
               </a:defRPr>
             </a:pPr>
             <a:r>
-              <a:t>Figure 4. Demand–supply dissociation: CSLC symptom prevalence rate (per 1,000 population) vs acute analgesic prescribing per surgery across 47 prefectures. Each marker shape represents a regional block. The near-zero correlation (r=0.03, P=0.85) indicates that prescribing variation is dissociated from symptom burden.</a:t>
+              <a:t>Figure 4. Demand–supply dissociation: CSLC symptom prevalence rate (per 1,000 population) vs acute analgesic prescribing per surgery across 47 prefectures. Each marker represents a regional block (distinguished by colour and shape). The near-zero correlation (r=0.03, P=0.85) indicates that prescribing variation is dissociated from symptom burden.</a:t>
             </a:r>
           </a:p>
         </p:txBody>

</xml_diff>